<commit_message>
Checkpoint experiment evidence and manuscript revision plan
</commit_message>
<xml_diff>
--- a/figures/hierarchical_feedback_architecture.pptx
+++ b/figures/hierarchical_feedback_architecture.pptx
@@ -3245,7 +3245,7 @@
               </a:defRPr>
             </a:pPr>
             <a:r>
-              <a:t>Source program when available</a:t>
+              <a:t>Source program</a:t>
             </a:r>
           </a:p>
           <a:p>
@@ -3261,7 +3261,7 @@
               </a:defRPr>
             </a:pPr>
             <a:r>
-              <a:t>Initial candidate and library</a:t>
+              <a:t>Initial target candidate</a:t>
             </a:r>
           </a:p>
           <a:p>
@@ -3571,7 +3571,7 @@
               </a:defRPr>
             </a:pPr>
             <a:r>
-              <a:t>Edit candidate or library</a:t>
+              <a:t>Edit permitted program code</a:t>
             </a:r>
           </a:p>
           <a:p>
@@ -3710,7 +3710,7 @@
               </a:defRPr>
             </a:pPr>
             <a:r>
-              <a:t>MindSpore via torch4ms</a:t>
+              <a:t>MindSpore and PyTorch</a:t>
             </a:r>
           </a:p>
           <a:p>
@@ -3742,7 +3742,7 @@
               </a:defRPr>
             </a:pPr>
             <a:r>
-              <a:t>Observe actual backend execution</a:t>
+              <a:t>Measure backend computations</a:t>
             </a:r>
           </a:p>
         </p:txBody>
@@ -4020,7 +4020,7 @@
               </a:defRPr>
             </a:pPr>
             <a:r>
-              <a:t>Current candidate and library</a:t>
+              <a:t>Current candidate and tests</a:t>
             </a:r>
           </a:p>
           <a:p>

</xml_diff>